<commit_message>
#176 footer-less EN decks (01-04) + remove seminar refs from lec-01 comments
- build_lecNN_en.py: disabled 'N/NN' slide-number footer; rebuilt lec-NN-en.pptx/pdf
  footer-less (verified: footer=0, Cyrillic=0, inline [N] citations kept).
- lec-01 speech.md/speech.en.md: removed 3 published seminar refs woven into slide
  comments (kept the point; unwrapped a leftover [If no questions:] cue). Changelog
  refs untouched (not published).

Co-Authored-By: Claude Opus 4.8 (1M context) <noreply@anthropic.com>
Claude-Session: https://claude.ai/code/session_01Gpxx9bSXjFd2bkWLexdYST
</commit_message>
<xml_diff>
--- a/library/lectures/lec-01/rendered/lec-01-en.pptx
+++ b/library/lectures/lec-01/rendered/lec-01-en.pptx
@@ -7540,45 +7540,6 @@
           </a:p>
         </p:txBody>
       </p:sp>
-      <p:sp>
-        <p:nvSpPr>
-          <p:cNvPr id="9" name="TextBox 8"/>
-          <p:cNvSpPr txBox="1"/>
-          <p:nvPr/>
-        </p:nvSpPr>
-        <p:spPr>
-          <a:xfrm>
-            <a:off x="11274552" y="6547104"/>
-            <a:ext cx="868680" cy="256032"/>
-          </a:xfrm>
-          <a:prstGeom prst="rect">
-            <a:avLst/>
-          </a:prstGeom>
-          <a:noFill/>
-        </p:spPr>
-        <p:txBody>
-          <a:bodyPr wrap="none" lIns="0" rIns="0" tIns="0" bIns="0">
-            <a:spAutoFit/>
-          </a:bodyPr>
-          <a:lstStyle/>
-          <a:p>
-            <a:pPr algn="r">
-              <a:lnSpc>
-                <a:spcPct val="100000"/>
-              </a:lnSpc>
-            </a:pPr>
-            <a:r>
-              <a:rPr sz="1000" i="1">
-                <a:solidFill>
-                  <a:srgbClr val="6B7685"/>
-                </a:solidFill>
-                <a:latin typeface="Arial"/>
-              </a:rPr>
-              <a:t>1 / 36</a:t>
-            </a:r>
-          </a:p>
-        </p:txBody>
-      </p:sp>
     </p:spTree>
   </p:cSld>
   <p:clrMapOvr>
@@ -9584,45 +9545,6 @@
                 <a:hlinkClick r:id="rId4"/>
               </a:rPr>
               <a:t>Dhar — Paradigm Shifts in AI, CACM (2024)</a:t>
-            </a:r>
-          </a:p>
-        </p:txBody>
-      </p:sp>
-      <p:sp>
-        <p:nvSpPr>
-          <p:cNvPr id="47" name="TextBox 46"/>
-          <p:cNvSpPr txBox="1"/>
-          <p:nvPr/>
-        </p:nvSpPr>
-        <p:spPr>
-          <a:xfrm>
-            <a:off x="11274552" y="6547104"/>
-            <a:ext cx="868680" cy="256032"/>
-          </a:xfrm>
-          <a:prstGeom prst="rect">
-            <a:avLst/>
-          </a:prstGeom>
-          <a:noFill/>
-        </p:spPr>
-        <p:txBody>
-          <a:bodyPr wrap="none" lIns="0" rIns="0" tIns="0" bIns="0">
-            <a:spAutoFit/>
-          </a:bodyPr>
-          <a:lstStyle/>
-          <a:p>
-            <a:pPr algn="r">
-              <a:lnSpc>
-                <a:spcPct val="100000"/>
-              </a:lnSpc>
-            </a:pPr>
-            <a:r>
-              <a:rPr sz="1000" i="1">
-                <a:solidFill>
-                  <a:srgbClr val="6B7685"/>
-                </a:solidFill>
-                <a:latin typeface="Arial"/>
-              </a:rPr>
-              <a:t>10 / 36</a:t>
             </a:r>
           </a:p>
         </p:txBody>
@@ -10730,45 +10652,6 @@
           </a:p>
         </p:txBody>
       </p:sp>
-      <p:sp>
-        <p:nvSpPr>
-          <p:cNvPr id="28" name="TextBox 27"/>
-          <p:cNvSpPr txBox="1"/>
-          <p:nvPr/>
-        </p:nvSpPr>
-        <p:spPr>
-          <a:xfrm>
-            <a:off x="11274552" y="6547104"/>
-            <a:ext cx="868680" cy="256032"/>
-          </a:xfrm>
-          <a:prstGeom prst="rect">
-            <a:avLst/>
-          </a:prstGeom>
-          <a:noFill/>
-        </p:spPr>
-        <p:txBody>
-          <a:bodyPr wrap="none" lIns="0" rIns="0" tIns="0" bIns="0">
-            <a:spAutoFit/>
-          </a:bodyPr>
-          <a:lstStyle/>
-          <a:p>
-            <a:pPr algn="r">
-              <a:lnSpc>
-                <a:spcPct val="100000"/>
-              </a:lnSpc>
-            </a:pPr>
-            <a:r>
-              <a:rPr sz="1000" i="1">
-                <a:solidFill>
-                  <a:srgbClr val="6B7685"/>
-                </a:solidFill>
-                <a:latin typeface="Arial"/>
-              </a:rPr>
-              <a:t>11 / 36</a:t>
-            </a:r>
-          </a:p>
-        </p:txBody>
-      </p:sp>
     </p:spTree>
   </p:cSld>
   <p:clrMapOvr>
@@ -12045,45 +11928,6 @@
           </a:p>
         </p:txBody>
       </p:sp>
-      <p:sp>
-        <p:nvSpPr>
-          <p:cNvPr id="29" name="TextBox 28"/>
-          <p:cNvSpPr txBox="1"/>
-          <p:nvPr/>
-        </p:nvSpPr>
-        <p:spPr>
-          <a:xfrm>
-            <a:off x="11274552" y="6547104"/>
-            <a:ext cx="868680" cy="256032"/>
-          </a:xfrm>
-          <a:prstGeom prst="rect">
-            <a:avLst/>
-          </a:prstGeom>
-          <a:noFill/>
-        </p:spPr>
-        <p:txBody>
-          <a:bodyPr wrap="none" lIns="0" rIns="0" tIns="0" bIns="0">
-            <a:spAutoFit/>
-          </a:bodyPr>
-          <a:lstStyle/>
-          <a:p>
-            <a:pPr algn="r">
-              <a:lnSpc>
-                <a:spcPct val="100000"/>
-              </a:lnSpc>
-            </a:pPr>
-            <a:r>
-              <a:rPr sz="1000" i="1">
-                <a:solidFill>
-                  <a:srgbClr val="6B7685"/>
-                </a:solidFill>
-                <a:latin typeface="Arial"/>
-              </a:rPr>
-              <a:t>12 / 36</a:t>
-            </a:r>
-          </a:p>
-        </p:txBody>
-      </p:sp>
     </p:spTree>
   </p:cSld>
   <p:clrMapOvr>
@@ -13465,45 +13309,6 @@
                 <a:hlinkClick r:id="rId7"/>
               </a:rPr>
               <a:t>Gerganov — llama.cpp / ggml.ai</a:t>
-            </a:r>
-          </a:p>
-        </p:txBody>
-      </p:sp>
-      <p:sp>
-        <p:nvSpPr>
-          <p:cNvPr id="30" name="TextBox 29"/>
-          <p:cNvSpPr txBox="1"/>
-          <p:nvPr/>
-        </p:nvSpPr>
-        <p:spPr>
-          <a:xfrm>
-            <a:off x="11274552" y="6547104"/>
-            <a:ext cx="868680" cy="256032"/>
-          </a:xfrm>
-          <a:prstGeom prst="rect">
-            <a:avLst/>
-          </a:prstGeom>
-          <a:noFill/>
-        </p:spPr>
-        <p:txBody>
-          <a:bodyPr wrap="none" lIns="0" rIns="0" tIns="0" bIns="0">
-            <a:spAutoFit/>
-          </a:bodyPr>
-          <a:lstStyle/>
-          <a:p>
-            <a:pPr algn="r">
-              <a:lnSpc>
-                <a:spcPct val="100000"/>
-              </a:lnSpc>
-            </a:pPr>
-            <a:r>
-              <a:rPr sz="1000" i="1">
-                <a:solidFill>
-                  <a:srgbClr val="6B7685"/>
-                </a:solidFill>
-                <a:latin typeface="Arial"/>
-              </a:rPr>
-              <a:t>13 / 36</a:t>
             </a:r>
           </a:p>
         </p:txBody>
@@ -14611,45 +14416,6 @@
           </a:p>
         </p:txBody>
       </p:sp>
-      <p:sp>
-        <p:nvSpPr>
-          <p:cNvPr id="28" name="TextBox 27"/>
-          <p:cNvSpPr txBox="1"/>
-          <p:nvPr/>
-        </p:nvSpPr>
-        <p:spPr>
-          <a:xfrm>
-            <a:off x="11274552" y="6547104"/>
-            <a:ext cx="868680" cy="256032"/>
-          </a:xfrm>
-          <a:prstGeom prst="rect">
-            <a:avLst/>
-          </a:prstGeom>
-          <a:noFill/>
-        </p:spPr>
-        <p:txBody>
-          <a:bodyPr wrap="none" lIns="0" rIns="0" tIns="0" bIns="0">
-            <a:spAutoFit/>
-          </a:bodyPr>
-          <a:lstStyle/>
-          <a:p>
-            <a:pPr algn="r">
-              <a:lnSpc>
-                <a:spcPct val="100000"/>
-              </a:lnSpc>
-            </a:pPr>
-            <a:r>
-              <a:rPr sz="1000" i="1">
-                <a:solidFill>
-                  <a:srgbClr val="6B7685"/>
-                </a:solidFill>
-                <a:latin typeface="Arial"/>
-              </a:rPr>
-              <a:t>14 / 36</a:t>
-            </a:r>
-          </a:p>
-        </p:txBody>
-      </p:sp>
     </p:spTree>
   </p:cSld>
   <p:clrMapOvr>
@@ -15717,45 +15483,6 @@
           </a:p>
         </p:txBody>
       </p:sp>
-      <p:sp>
-        <p:nvSpPr>
-          <p:cNvPr id="25" name="TextBox 24"/>
-          <p:cNvSpPr txBox="1"/>
-          <p:nvPr/>
-        </p:nvSpPr>
-        <p:spPr>
-          <a:xfrm>
-            <a:off x="11274552" y="6547104"/>
-            <a:ext cx="868680" cy="256032"/>
-          </a:xfrm>
-          <a:prstGeom prst="rect">
-            <a:avLst/>
-          </a:prstGeom>
-          <a:noFill/>
-        </p:spPr>
-        <p:txBody>
-          <a:bodyPr wrap="none" lIns="0" rIns="0" tIns="0" bIns="0">
-            <a:spAutoFit/>
-          </a:bodyPr>
-          <a:lstStyle/>
-          <a:p>
-            <a:pPr algn="r">
-              <a:lnSpc>
-                <a:spcPct val="100000"/>
-              </a:lnSpc>
-            </a:pPr>
-            <a:r>
-              <a:rPr sz="1000" i="1">
-                <a:solidFill>
-                  <a:srgbClr val="6B7685"/>
-                </a:solidFill>
-                <a:latin typeface="Arial"/>
-              </a:rPr>
-              <a:t>15 / 36</a:t>
-            </a:r>
-          </a:p>
-        </p:txBody>
-      </p:sp>
     </p:spTree>
   </p:cSld>
   <p:clrMapOvr>
@@ -18713,45 +18440,6 @@
           </a:p>
         </p:txBody>
       </p:sp>
-      <p:sp>
-        <p:nvSpPr>
-          <p:cNvPr id="72" name="TextBox 71"/>
-          <p:cNvSpPr txBox="1"/>
-          <p:nvPr/>
-        </p:nvSpPr>
-        <p:spPr>
-          <a:xfrm>
-            <a:off x="11274552" y="6547104"/>
-            <a:ext cx="868680" cy="256032"/>
-          </a:xfrm>
-          <a:prstGeom prst="rect">
-            <a:avLst/>
-          </a:prstGeom>
-          <a:noFill/>
-        </p:spPr>
-        <p:txBody>
-          <a:bodyPr wrap="none" lIns="0" rIns="0" tIns="0" bIns="0">
-            <a:spAutoFit/>
-          </a:bodyPr>
-          <a:lstStyle/>
-          <a:p>
-            <a:pPr algn="r">
-              <a:lnSpc>
-                <a:spcPct val="100000"/>
-              </a:lnSpc>
-            </a:pPr>
-            <a:r>
-              <a:rPr sz="1000" i="1">
-                <a:solidFill>
-                  <a:srgbClr val="6B7685"/>
-                </a:solidFill>
-                <a:latin typeface="Arial"/>
-              </a:rPr>
-              <a:t>16 / 36</a:t>
-            </a:r>
-          </a:p>
-        </p:txBody>
-      </p:sp>
     </p:spTree>
   </p:cSld>
   <p:clrMapOvr>
@@ -19908,45 +19596,6 @@
           </a:p>
         </p:txBody>
       </p:sp>
-      <p:sp>
-        <p:nvSpPr>
-          <p:cNvPr id="29" name="TextBox 28"/>
-          <p:cNvSpPr txBox="1"/>
-          <p:nvPr/>
-        </p:nvSpPr>
-        <p:spPr>
-          <a:xfrm>
-            <a:off x="11274552" y="6547104"/>
-            <a:ext cx="868680" cy="256032"/>
-          </a:xfrm>
-          <a:prstGeom prst="rect">
-            <a:avLst/>
-          </a:prstGeom>
-          <a:noFill/>
-        </p:spPr>
-        <p:txBody>
-          <a:bodyPr wrap="none" lIns="0" rIns="0" tIns="0" bIns="0">
-            <a:spAutoFit/>
-          </a:bodyPr>
-          <a:lstStyle/>
-          <a:p>
-            <a:pPr algn="r">
-              <a:lnSpc>
-                <a:spcPct val="100000"/>
-              </a:lnSpc>
-            </a:pPr>
-            <a:r>
-              <a:rPr sz="1000" i="1">
-                <a:solidFill>
-                  <a:srgbClr val="6B7685"/>
-                </a:solidFill>
-                <a:latin typeface="Arial"/>
-              </a:rPr>
-              <a:t>17 / 36</a:t>
-            </a:r>
-          </a:p>
-        </p:txBody>
-      </p:sp>
     </p:spTree>
   </p:cSld>
   <p:clrMapOvr>
@@ -21847,45 +21496,6 @@
           </a:p>
         </p:txBody>
       </p:sp>
-      <p:sp>
-        <p:nvSpPr>
-          <p:cNvPr id="45" name="TextBox 44"/>
-          <p:cNvSpPr txBox="1"/>
-          <p:nvPr/>
-        </p:nvSpPr>
-        <p:spPr>
-          <a:xfrm>
-            <a:off x="11274552" y="6547104"/>
-            <a:ext cx="868680" cy="256032"/>
-          </a:xfrm>
-          <a:prstGeom prst="rect">
-            <a:avLst/>
-          </a:prstGeom>
-          <a:noFill/>
-        </p:spPr>
-        <p:txBody>
-          <a:bodyPr wrap="none" lIns="0" rIns="0" tIns="0" bIns="0">
-            <a:spAutoFit/>
-          </a:bodyPr>
-          <a:lstStyle/>
-          <a:p>
-            <a:pPr algn="r">
-              <a:lnSpc>
-                <a:spcPct val="100000"/>
-              </a:lnSpc>
-            </a:pPr>
-            <a:r>
-              <a:rPr sz="1000" i="1">
-                <a:solidFill>
-                  <a:srgbClr val="6B7685"/>
-                </a:solidFill>
-                <a:latin typeface="Arial"/>
-              </a:rPr>
-              <a:t>18 / 36</a:t>
-            </a:r>
-          </a:p>
-        </p:txBody>
-      </p:sp>
     </p:spTree>
   </p:cSld>
   <p:clrMapOvr>
@@ -23421,45 +23031,6 @@
                 <a:hlinkClick r:id="rId2"/>
               </a:rPr>
               <a:t>Anthropic — Building Effective Agents (2024)</a:t>
-            </a:r>
-          </a:p>
-        </p:txBody>
-      </p:sp>
-      <p:sp>
-        <p:nvSpPr>
-          <p:cNvPr id="37" name="TextBox 36"/>
-          <p:cNvSpPr txBox="1"/>
-          <p:nvPr/>
-        </p:nvSpPr>
-        <p:spPr>
-          <a:xfrm>
-            <a:off x="11274552" y="6547104"/>
-            <a:ext cx="868680" cy="256032"/>
-          </a:xfrm>
-          <a:prstGeom prst="rect">
-            <a:avLst/>
-          </a:prstGeom>
-          <a:noFill/>
-        </p:spPr>
-        <p:txBody>
-          <a:bodyPr wrap="none" lIns="0" rIns="0" tIns="0" bIns="0">
-            <a:spAutoFit/>
-          </a:bodyPr>
-          <a:lstStyle/>
-          <a:p>
-            <a:pPr algn="r">
-              <a:lnSpc>
-                <a:spcPct val="100000"/>
-              </a:lnSpc>
-            </a:pPr>
-            <a:r>
-              <a:rPr sz="1000" i="1">
-                <a:solidFill>
-                  <a:srgbClr val="6B7685"/>
-                </a:solidFill>
-                <a:latin typeface="Arial"/>
-              </a:rPr>
-              <a:t>19 / 36</a:t>
             </a:r>
           </a:p>
         </p:txBody>
@@ -23652,45 +23223,6 @@
           </a:p>
         </p:txBody>
       </p:sp>
-      <p:sp>
-        <p:nvSpPr>
-          <p:cNvPr id="6" name="TextBox 5"/>
-          <p:cNvSpPr txBox="1"/>
-          <p:nvPr/>
-        </p:nvSpPr>
-        <p:spPr>
-          <a:xfrm>
-            <a:off x="11274552" y="6547104"/>
-            <a:ext cx="868680" cy="256032"/>
-          </a:xfrm>
-          <a:prstGeom prst="rect">
-            <a:avLst/>
-          </a:prstGeom>
-          <a:noFill/>
-        </p:spPr>
-        <p:txBody>
-          <a:bodyPr wrap="none" lIns="0" rIns="0" tIns="0" bIns="0">
-            <a:spAutoFit/>
-          </a:bodyPr>
-          <a:lstStyle/>
-          <a:p>
-            <a:pPr algn="r">
-              <a:lnSpc>
-                <a:spcPct val="100000"/>
-              </a:lnSpc>
-            </a:pPr>
-            <a:r>
-              <a:rPr sz="1000" i="1">
-                <a:solidFill>
-                  <a:srgbClr val="6B7685"/>
-                </a:solidFill>
-                <a:latin typeface="Arial"/>
-              </a:rPr>
-              <a:t>2 / 36</a:t>
-            </a:r>
-          </a:p>
-        </p:txBody>
-      </p:sp>
     </p:spTree>
   </p:cSld>
   <p:clrMapOvr>
@@ -24513,45 +24045,6 @@
           </a:p>
         </p:txBody>
       </p:sp>
-      <p:sp>
-        <p:nvSpPr>
-          <p:cNvPr id="17" name="TextBox 16"/>
-          <p:cNvSpPr txBox="1"/>
-          <p:nvPr/>
-        </p:nvSpPr>
-        <p:spPr>
-          <a:xfrm>
-            <a:off x="11274552" y="6547104"/>
-            <a:ext cx="868680" cy="256032"/>
-          </a:xfrm>
-          <a:prstGeom prst="rect">
-            <a:avLst/>
-          </a:prstGeom>
-          <a:noFill/>
-        </p:spPr>
-        <p:txBody>
-          <a:bodyPr wrap="none" lIns="0" rIns="0" tIns="0" bIns="0">
-            <a:spAutoFit/>
-          </a:bodyPr>
-          <a:lstStyle/>
-          <a:p>
-            <a:pPr algn="r">
-              <a:lnSpc>
-                <a:spcPct val="100000"/>
-              </a:lnSpc>
-            </a:pPr>
-            <a:r>
-              <a:rPr sz="1000" i="1">
-                <a:solidFill>
-                  <a:srgbClr val="6B7685"/>
-                </a:solidFill>
-                <a:latin typeface="Arial"/>
-              </a:rPr>
-              <a:t>20 / 36</a:t>
-            </a:r>
-          </a:p>
-        </p:txBody>
-      </p:sp>
     </p:spTree>
   </p:cSld>
   <p:clrMapOvr>
@@ -26429,45 +25922,6 @@
           </a:p>
         </p:txBody>
       </p:sp>
-      <p:sp>
-        <p:nvSpPr>
-          <p:cNvPr id="43" name="TextBox 42"/>
-          <p:cNvSpPr txBox="1"/>
-          <p:nvPr/>
-        </p:nvSpPr>
-        <p:spPr>
-          <a:xfrm>
-            <a:off x="11274552" y="6547104"/>
-            <a:ext cx="868680" cy="256032"/>
-          </a:xfrm>
-          <a:prstGeom prst="rect">
-            <a:avLst/>
-          </a:prstGeom>
-          <a:noFill/>
-        </p:spPr>
-        <p:txBody>
-          <a:bodyPr wrap="none" lIns="0" rIns="0" tIns="0" bIns="0">
-            <a:spAutoFit/>
-          </a:bodyPr>
-          <a:lstStyle/>
-          <a:p>
-            <a:pPr algn="r">
-              <a:lnSpc>
-                <a:spcPct val="100000"/>
-              </a:lnSpc>
-            </a:pPr>
-            <a:r>
-              <a:rPr sz="1000" i="1">
-                <a:solidFill>
-                  <a:srgbClr val="6B7685"/>
-                </a:solidFill>
-                <a:latin typeface="Arial"/>
-              </a:rPr>
-              <a:t>21 / 36</a:t>
-            </a:r>
-          </a:p>
-        </p:txBody>
-      </p:sp>
     </p:spTree>
   </p:cSld>
   <p:clrMapOvr>
@@ -28446,45 +27900,6 @@
           </a:p>
         </p:txBody>
       </p:sp>
-      <p:sp>
-        <p:nvSpPr>
-          <p:cNvPr id="48" name="TextBox 47"/>
-          <p:cNvSpPr txBox="1"/>
-          <p:nvPr/>
-        </p:nvSpPr>
-        <p:spPr>
-          <a:xfrm>
-            <a:off x="11274552" y="6547104"/>
-            <a:ext cx="868680" cy="256032"/>
-          </a:xfrm>
-          <a:prstGeom prst="rect">
-            <a:avLst/>
-          </a:prstGeom>
-          <a:noFill/>
-        </p:spPr>
-        <p:txBody>
-          <a:bodyPr wrap="none" lIns="0" rIns="0" tIns="0" bIns="0">
-            <a:spAutoFit/>
-          </a:bodyPr>
-          <a:lstStyle/>
-          <a:p>
-            <a:pPr algn="r">
-              <a:lnSpc>
-                <a:spcPct val="100000"/>
-              </a:lnSpc>
-            </a:pPr>
-            <a:r>
-              <a:rPr sz="1000" i="1">
-                <a:solidFill>
-                  <a:srgbClr val="6B7685"/>
-                </a:solidFill>
-                <a:latin typeface="Arial"/>
-              </a:rPr>
-              <a:t>22 / 36</a:t>
-            </a:r>
-          </a:p>
-        </p:txBody>
-      </p:sp>
     </p:spTree>
   </p:cSld>
   <p:clrMapOvr>
@@ -30239,45 +29654,6 @@
           </a:p>
         </p:txBody>
       </p:sp>
-      <p:sp>
-        <p:nvSpPr>
-          <p:cNvPr id="43" name="TextBox 42"/>
-          <p:cNvSpPr txBox="1"/>
-          <p:nvPr/>
-        </p:nvSpPr>
-        <p:spPr>
-          <a:xfrm>
-            <a:off x="11274552" y="6547104"/>
-            <a:ext cx="868680" cy="256032"/>
-          </a:xfrm>
-          <a:prstGeom prst="rect">
-            <a:avLst/>
-          </a:prstGeom>
-          <a:noFill/>
-        </p:spPr>
-        <p:txBody>
-          <a:bodyPr wrap="none" lIns="0" rIns="0" tIns="0" bIns="0">
-            <a:spAutoFit/>
-          </a:bodyPr>
-          <a:lstStyle/>
-          <a:p>
-            <a:pPr algn="r">
-              <a:lnSpc>
-                <a:spcPct val="100000"/>
-              </a:lnSpc>
-            </a:pPr>
-            <a:r>
-              <a:rPr sz="1000" i="1">
-                <a:solidFill>
-                  <a:srgbClr val="6B7685"/>
-                </a:solidFill>
-                <a:latin typeface="Arial"/>
-              </a:rPr>
-              <a:t>23 / 36</a:t>
-            </a:r>
-          </a:p>
-        </p:txBody>
-      </p:sp>
     </p:spTree>
   </p:cSld>
   <p:clrMapOvr>
@@ -31613,45 +30989,6 @@
           </a:p>
         </p:txBody>
       </p:sp>
-      <p:sp>
-        <p:nvSpPr>
-          <p:cNvPr id="34" name="TextBox 33"/>
-          <p:cNvSpPr txBox="1"/>
-          <p:nvPr/>
-        </p:nvSpPr>
-        <p:spPr>
-          <a:xfrm>
-            <a:off x="11274552" y="6547104"/>
-            <a:ext cx="868680" cy="256032"/>
-          </a:xfrm>
-          <a:prstGeom prst="rect">
-            <a:avLst/>
-          </a:prstGeom>
-          <a:noFill/>
-        </p:spPr>
-        <p:txBody>
-          <a:bodyPr wrap="none" lIns="0" rIns="0" tIns="0" bIns="0">
-            <a:spAutoFit/>
-          </a:bodyPr>
-          <a:lstStyle/>
-          <a:p>
-            <a:pPr algn="r">
-              <a:lnSpc>
-                <a:spcPct val="100000"/>
-              </a:lnSpc>
-            </a:pPr>
-            <a:r>
-              <a:rPr sz="1000" i="1">
-                <a:solidFill>
-                  <a:srgbClr val="6B7685"/>
-                </a:solidFill>
-                <a:latin typeface="Arial"/>
-              </a:rPr>
-              <a:t>24 / 36</a:t>
-            </a:r>
-          </a:p>
-        </p:txBody>
-      </p:sp>
     </p:spTree>
   </p:cSld>
   <p:clrMapOvr>
@@ -32867,45 +32204,6 @@
                 <a:hlinkClick r:id="rId4"/>
               </a:rPr>
               <a:t>Ng — Four Agentic Design Patterns (2024)</a:t>
-            </a:r>
-          </a:p>
-        </p:txBody>
-      </p:sp>
-      <p:sp>
-        <p:nvSpPr>
-          <p:cNvPr id="28" name="TextBox 27"/>
-          <p:cNvSpPr txBox="1"/>
-          <p:nvPr/>
-        </p:nvSpPr>
-        <p:spPr>
-          <a:xfrm>
-            <a:off x="11274552" y="6547104"/>
-            <a:ext cx="868680" cy="256032"/>
-          </a:xfrm>
-          <a:prstGeom prst="rect">
-            <a:avLst/>
-          </a:prstGeom>
-          <a:noFill/>
-        </p:spPr>
-        <p:txBody>
-          <a:bodyPr wrap="none" lIns="0" rIns="0" tIns="0" bIns="0">
-            <a:spAutoFit/>
-          </a:bodyPr>
-          <a:lstStyle/>
-          <a:p>
-            <a:pPr algn="r">
-              <a:lnSpc>
-                <a:spcPct val="100000"/>
-              </a:lnSpc>
-            </a:pPr>
-            <a:r>
-              <a:rPr sz="1000" i="1">
-                <a:solidFill>
-                  <a:srgbClr val="6B7685"/>
-                </a:solidFill>
-                <a:latin typeface="Arial"/>
-              </a:rPr>
-              <a:t>25 / 36</a:t>
             </a:r>
           </a:p>
         </p:txBody>
@@ -34173,45 +33471,6 @@
           </a:p>
         </p:txBody>
       </p:sp>
-      <p:sp>
-        <p:nvSpPr>
-          <p:cNvPr id="29" name="TextBox 28"/>
-          <p:cNvSpPr txBox="1"/>
-          <p:nvPr/>
-        </p:nvSpPr>
-        <p:spPr>
-          <a:xfrm>
-            <a:off x="11274552" y="6547104"/>
-            <a:ext cx="868680" cy="256032"/>
-          </a:xfrm>
-          <a:prstGeom prst="rect">
-            <a:avLst/>
-          </a:prstGeom>
-          <a:noFill/>
-        </p:spPr>
-        <p:txBody>
-          <a:bodyPr wrap="none" lIns="0" rIns="0" tIns="0" bIns="0">
-            <a:spAutoFit/>
-          </a:bodyPr>
-          <a:lstStyle/>
-          <a:p>
-            <a:pPr algn="r">
-              <a:lnSpc>
-                <a:spcPct val="100000"/>
-              </a:lnSpc>
-            </a:pPr>
-            <a:r>
-              <a:rPr sz="1000" i="1">
-                <a:solidFill>
-                  <a:srgbClr val="6B7685"/>
-                </a:solidFill>
-                <a:latin typeface="Arial"/>
-              </a:rPr>
-              <a:t>26 / 36</a:t>
-            </a:r>
-          </a:p>
-        </p:txBody>
-      </p:sp>
     </p:spTree>
   </p:cSld>
   <p:clrMapOvr>
@@ -35355,45 +34614,6 @@
           </a:p>
         </p:txBody>
       </p:sp>
-      <p:sp>
-        <p:nvSpPr>
-          <p:cNvPr id="27" name="TextBox 26"/>
-          <p:cNvSpPr txBox="1"/>
-          <p:nvPr/>
-        </p:nvSpPr>
-        <p:spPr>
-          <a:xfrm>
-            <a:off x="11274552" y="6547104"/>
-            <a:ext cx="868680" cy="256032"/>
-          </a:xfrm>
-          <a:prstGeom prst="rect">
-            <a:avLst/>
-          </a:prstGeom>
-          <a:noFill/>
-        </p:spPr>
-        <p:txBody>
-          <a:bodyPr wrap="none" lIns="0" rIns="0" tIns="0" bIns="0">
-            <a:spAutoFit/>
-          </a:bodyPr>
-          <a:lstStyle/>
-          <a:p>
-            <a:pPr algn="r">
-              <a:lnSpc>
-                <a:spcPct val="100000"/>
-              </a:lnSpc>
-            </a:pPr>
-            <a:r>
-              <a:rPr sz="1000" i="1">
-                <a:solidFill>
-                  <a:srgbClr val="6B7685"/>
-                </a:solidFill>
-                <a:latin typeface="Arial"/>
-              </a:rPr>
-              <a:t>27 / 36</a:t>
-            </a:r>
-          </a:p>
-        </p:txBody>
-      </p:sp>
     </p:spTree>
   </p:cSld>
   <p:clrMapOvr>
@@ -36572,45 +35792,6 @@
           </a:p>
         </p:txBody>
       </p:sp>
-      <p:sp>
-        <p:nvSpPr>
-          <p:cNvPr id="27" name="TextBox 26"/>
-          <p:cNvSpPr txBox="1"/>
-          <p:nvPr/>
-        </p:nvSpPr>
-        <p:spPr>
-          <a:xfrm>
-            <a:off x="11274552" y="6547104"/>
-            <a:ext cx="868680" cy="256032"/>
-          </a:xfrm>
-          <a:prstGeom prst="rect">
-            <a:avLst/>
-          </a:prstGeom>
-          <a:noFill/>
-        </p:spPr>
-        <p:txBody>
-          <a:bodyPr wrap="none" lIns="0" rIns="0" tIns="0" bIns="0">
-            <a:spAutoFit/>
-          </a:bodyPr>
-          <a:lstStyle/>
-          <a:p>
-            <a:pPr algn="r">
-              <a:lnSpc>
-                <a:spcPct val="100000"/>
-              </a:lnSpc>
-            </a:pPr>
-            <a:r>
-              <a:rPr sz="1000" i="1">
-                <a:solidFill>
-                  <a:srgbClr val="6B7685"/>
-                </a:solidFill>
-                <a:latin typeface="Arial"/>
-              </a:rPr>
-              <a:t>28 / 36</a:t>
-            </a:r>
-          </a:p>
-        </p:txBody>
-      </p:sp>
     </p:spTree>
   </p:cSld>
   <p:clrMapOvr>
@@ -37544,45 +36725,6 @@
           </a:p>
         </p:txBody>
       </p:sp>
-      <p:sp>
-        <p:nvSpPr>
-          <p:cNvPr id="23" name="TextBox 22"/>
-          <p:cNvSpPr txBox="1"/>
-          <p:nvPr/>
-        </p:nvSpPr>
-        <p:spPr>
-          <a:xfrm>
-            <a:off x="11274552" y="6547104"/>
-            <a:ext cx="868680" cy="256032"/>
-          </a:xfrm>
-          <a:prstGeom prst="rect">
-            <a:avLst/>
-          </a:prstGeom>
-          <a:noFill/>
-        </p:spPr>
-        <p:txBody>
-          <a:bodyPr wrap="none" lIns="0" rIns="0" tIns="0" bIns="0">
-            <a:spAutoFit/>
-          </a:bodyPr>
-          <a:lstStyle/>
-          <a:p>
-            <a:pPr algn="r">
-              <a:lnSpc>
-                <a:spcPct val="100000"/>
-              </a:lnSpc>
-            </a:pPr>
-            <a:r>
-              <a:rPr sz="1000" i="1">
-                <a:solidFill>
-                  <a:srgbClr val="6B7685"/>
-                </a:solidFill>
-                <a:latin typeface="Arial"/>
-              </a:rPr>
-              <a:t>29 / 36</a:t>
-            </a:r>
-          </a:p>
-        </p:txBody>
-      </p:sp>
     </p:spTree>
   </p:cSld>
   <p:clrMapOvr>
@@ -38242,45 +37384,6 @@
           </a:p>
         </p:txBody>
       </p:sp>
-      <p:sp>
-        <p:nvSpPr>
-          <p:cNvPr id="16" name="TextBox 15"/>
-          <p:cNvSpPr txBox="1"/>
-          <p:nvPr/>
-        </p:nvSpPr>
-        <p:spPr>
-          <a:xfrm>
-            <a:off x="11274552" y="6547104"/>
-            <a:ext cx="868680" cy="256032"/>
-          </a:xfrm>
-          <a:prstGeom prst="rect">
-            <a:avLst/>
-          </a:prstGeom>
-          <a:noFill/>
-        </p:spPr>
-        <p:txBody>
-          <a:bodyPr wrap="none" lIns="0" rIns="0" tIns="0" bIns="0">
-            <a:spAutoFit/>
-          </a:bodyPr>
-          <a:lstStyle/>
-          <a:p>
-            <a:pPr algn="r">
-              <a:lnSpc>
-                <a:spcPct val="100000"/>
-              </a:lnSpc>
-            </a:pPr>
-            <a:r>
-              <a:rPr sz="1000" i="1">
-                <a:solidFill>
-                  <a:srgbClr val="6B7685"/>
-                </a:solidFill>
-                <a:latin typeface="Arial"/>
-              </a:rPr>
-              <a:t>3 / 36</a:t>
-            </a:r>
-          </a:p>
-        </p:txBody>
-      </p:sp>
     </p:spTree>
   </p:cSld>
   <p:clrMapOvr>
@@ -39454,45 +38557,6 @@
                 <a:hlinkClick r:id="rId3"/>
               </a:rPr>
               <a:t>Bostrom — Superintelligence (2014)</a:t>
-            </a:r>
-          </a:p>
-        </p:txBody>
-      </p:sp>
-      <p:sp>
-        <p:nvSpPr>
-          <p:cNvPr id="29" name="TextBox 28"/>
-          <p:cNvSpPr txBox="1"/>
-          <p:nvPr/>
-        </p:nvSpPr>
-        <p:spPr>
-          <a:xfrm>
-            <a:off x="11274552" y="6547104"/>
-            <a:ext cx="868680" cy="256032"/>
-          </a:xfrm>
-          <a:prstGeom prst="rect">
-            <a:avLst/>
-          </a:prstGeom>
-          <a:noFill/>
-        </p:spPr>
-        <p:txBody>
-          <a:bodyPr wrap="none" lIns="0" rIns="0" tIns="0" bIns="0">
-            <a:spAutoFit/>
-          </a:bodyPr>
-          <a:lstStyle/>
-          <a:p>
-            <a:pPr algn="r">
-              <a:lnSpc>
-                <a:spcPct val="100000"/>
-              </a:lnSpc>
-            </a:pPr>
-            <a:r>
-              <a:rPr sz="1000" i="1">
-                <a:solidFill>
-                  <a:srgbClr val="6B7685"/>
-                </a:solidFill>
-                <a:latin typeface="Arial"/>
-              </a:rPr>
-              <a:t>30 / 36</a:t>
             </a:r>
           </a:p>
         </p:txBody>
@@ -40600,45 +39664,6 @@
           </a:p>
         </p:txBody>
       </p:sp>
-      <p:sp>
-        <p:nvSpPr>
-          <p:cNvPr id="28" name="TextBox 27"/>
-          <p:cNvSpPr txBox="1"/>
-          <p:nvPr/>
-        </p:nvSpPr>
-        <p:spPr>
-          <a:xfrm>
-            <a:off x="11274552" y="6547104"/>
-            <a:ext cx="868680" cy="256032"/>
-          </a:xfrm>
-          <a:prstGeom prst="rect">
-            <a:avLst/>
-          </a:prstGeom>
-          <a:noFill/>
-        </p:spPr>
-        <p:txBody>
-          <a:bodyPr wrap="none" lIns="0" rIns="0" tIns="0" bIns="0">
-            <a:spAutoFit/>
-          </a:bodyPr>
-          <a:lstStyle/>
-          <a:p>
-            <a:pPr algn="r">
-              <a:lnSpc>
-                <a:spcPct val="100000"/>
-              </a:lnSpc>
-            </a:pPr>
-            <a:r>
-              <a:rPr sz="1000" i="1">
-                <a:solidFill>
-                  <a:srgbClr val="6B7685"/>
-                </a:solidFill>
-                <a:latin typeface="Arial"/>
-              </a:rPr>
-              <a:t>31 / 36</a:t>
-            </a:r>
-          </a:p>
-        </p:txBody>
-      </p:sp>
     </p:spTree>
   </p:cSld>
   <p:clrMapOvr>
@@ -41281,45 +40306,6 @@
           </a:p>
         </p:txBody>
       </p:sp>
-      <p:sp>
-        <p:nvSpPr>
-          <p:cNvPr id="17" name="TextBox 16"/>
-          <p:cNvSpPr txBox="1"/>
-          <p:nvPr/>
-        </p:nvSpPr>
-        <p:spPr>
-          <a:xfrm>
-            <a:off x="11274552" y="6547104"/>
-            <a:ext cx="868680" cy="256032"/>
-          </a:xfrm>
-          <a:prstGeom prst="rect">
-            <a:avLst/>
-          </a:prstGeom>
-          <a:noFill/>
-        </p:spPr>
-        <p:txBody>
-          <a:bodyPr wrap="none" lIns="0" rIns="0" tIns="0" bIns="0">
-            <a:spAutoFit/>
-          </a:bodyPr>
-          <a:lstStyle/>
-          <a:p>
-            <a:pPr algn="r">
-              <a:lnSpc>
-                <a:spcPct val="100000"/>
-              </a:lnSpc>
-            </a:pPr>
-            <a:r>
-              <a:rPr sz="1000" i="1">
-                <a:solidFill>
-                  <a:srgbClr val="6B7685"/>
-                </a:solidFill>
-                <a:latin typeface="Arial"/>
-              </a:rPr>
-              <a:t>32 / 36</a:t>
-            </a:r>
-          </a:p>
-        </p:txBody>
-      </p:sp>
     </p:spTree>
   </p:cSld>
   <p:clrMapOvr>
@@ -42806,45 +41792,6 @@
                 <a:latin typeface="Arial"/>
               </a:rPr>
               <a:t>◆ — module tests M1/M2/M3, at the end of each of the first three modules.</a:t>
-            </a:r>
-          </a:p>
-        </p:txBody>
-      </p:sp>
-      <p:sp>
-        <p:nvSpPr>
-          <p:cNvPr id="38" name="TextBox 37"/>
-          <p:cNvSpPr txBox="1"/>
-          <p:nvPr/>
-        </p:nvSpPr>
-        <p:spPr>
-          <a:xfrm>
-            <a:off x="11274552" y="6547104"/>
-            <a:ext cx="868680" cy="256032"/>
-          </a:xfrm>
-          <a:prstGeom prst="rect">
-            <a:avLst/>
-          </a:prstGeom>
-          <a:noFill/>
-        </p:spPr>
-        <p:txBody>
-          <a:bodyPr wrap="none" lIns="0" rIns="0" tIns="0" bIns="0">
-            <a:spAutoFit/>
-          </a:bodyPr>
-          <a:lstStyle/>
-          <a:p>
-            <a:pPr algn="r">
-              <a:lnSpc>
-                <a:spcPct val="100000"/>
-              </a:lnSpc>
-            </a:pPr>
-            <a:r>
-              <a:rPr sz="1000" i="1">
-                <a:solidFill>
-                  <a:srgbClr val="6B7685"/>
-                </a:solidFill>
-                <a:latin typeface="Arial"/>
-              </a:rPr>
-              <a:t>33 / 36</a:t>
             </a:r>
           </a:p>
         </p:txBody>
@@ -43046,45 +41993,6 @@
           </a:p>
         </p:txBody>
       </p:sp>
-      <p:sp>
-        <p:nvSpPr>
-          <p:cNvPr id="5" name="TextBox 4"/>
-          <p:cNvSpPr txBox="1"/>
-          <p:nvPr/>
-        </p:nvSpPr>
-        <p:spPr>
-          <a:xfrm>
-            <a:off x="11274552" y="6547104"/>
-            <a:ext cx="868680" cy="256032"/>
-          </a:xfrm>
-          <a:prstGeom prst="rect">
-            <a:avLst/>
-          </a:prstGeom>
-          <a:noFill/>
-        </p:spPr>
-        <p:txBody>
-          <a:bodyPr wrap="none" lIns="0" rIns="0" tIns="0" bIns="0">
-            <a:spAutoFit/>
-          </a:bodyPr>
-          <a:lstStyle/>
-          <a:p>
-            <a:pPr algn="r">
-              <a:lnSpc>
-                <a:spcPct val="100000"/>
-              </a:lnSpc>
-            </a:pPr>
-            <a:r>
-              <a:rPr sz="1000" i="1">
-                <a:solidFill>
-                  <a:srgbClr val="6B7685"/>
-                </a:solidFill>
-                <a:latin typeface="Arial"/>
-              </a:rPr>
-              <a:t>34 / 36</a:t>
-            </a:r>
-          </a:p>
-        </p:txBody>
-      </p:sp>
     </p:spTree>
   </p:cSld>
   <p:clrMapOvr>
@@ -43777,45 +42685,6 @@
                 <a:latin typeface="Arial"/>
               </a:rPr>
               <a:t>These 4 concepts explain the behavior of every modern LLM — from ChatGPT to DeepSeek.</a:t>
-            </a:r>
-          </a:p>
-        </p:txBody>
-      </p:sp>
-      <p:sp>
-        <p:nvSpPr>
-          <p:cNvPr id="20" name="TextBox 19"/>
-          <p:cNvSpPr txBox="1"/>
-          <p:nvPr/>
-        </p:nvSpPr>
-        <p:spPr>
-          <a:xfrm>
-            <a:off x="11274552" y="6547104"/>
-            <a:ext cx="868680" cy="256032"/>
-          </a:xfrm>
-          <a:prstGeom prst="rect">
-            <a:avLst/>
-          </a:prstGeom>
-          <a:noFill/>
-        </p:spPr>
-        <p:txBody>
-          <a:bodyPr wrap="none" lIns="0" rIns="0" tIns="0" bIns="0">
-            <a:spAutoFit/>
-          </a:bodyPr>
-          <a:lstStyle/>
-          <a:p>
-            <a:pPr algn="r">
-              <a:lnSpc>
-                <a:spcPct val="100000"/>
-              </a:lnSpc>
-            </a:pPr>
-            <a:r>
-              <a:rPr sz="1000" i="1">
-                <a:solidFill>
-                  <a:srgbClr val="6B7685"/>
-                </a:solidFill>
-                <a:latin typeface="Arial"/>
-              </a:rPr>
-              <a:t>35 / 36</a:t>
             </a:r>
           </a:p>
         </p:txBody>
@@ -43920,45 +42789,6 @@
                 <a:latin typeface="Arial"/>
               </a:rPr>
               <a:t>Thank you</a:t>
-            </a:r>
-          </a:p>
-        </p:txBody>
-      </p:sp>
-      <p:sp>
-        <p:nvSpPr>
-          <p:cNvPr id="4" name="TextBox 3"/>
-          <p:cNvSpPr txBox="1"/>
-          <p:nvPr/>
-        </p:nvSpPr>
-        <p:spPr>
-          <a:xfrm>
-            <a:off x="11274552" y="6547104"/>
-            <a:ext cx="868680" cy="256032"/>
-          </a:xfrm>
-          <a:prstGeom prst="rect">
-            <a:avLst/>
-          </a:prstGeom>
-          <a:noFill/>
-        </p:spPr>
-        <p:txBody>
-          <a:bodyPr wrap="none" lIns="0" rIns="0" tIns="0" bIns="0">
-            <a:spAutoFit/>
-          </a:bodyPr>
-          <a:lstStyle/>
-          <a:p>
-            <a:pPr algn="r">
-              <a:lnSpc>
-                <a:spcPct val="100000"/>
-              </a:lnSpc>
-            </a:pPr>
-            <a:r>
-              <a:rPr sz="1000" i="1">
-                <a:solidFill>
-                  <a:srgbClr val="6B7685"/>
-                </a:solidFill>
-                <a:latin typeface="Arial"/>
-              </a:rPr>
-              <a:t>36 / 36</a:t>
             </a:r>
           </a:p>
         </p:txBody>
@@ -44259,45 +43089,6 @@
           </a:p>
         </p:txBody>
       </p:sp>
-      <p:sp>
-        <p:nvSpPr>
-          <p:cNvPr id="9" name="TextBox 8"/>
-          <p:cNvSpPr txBox="1"/>
-          <p:nvPr/>
-        </p:nvSpPr>
-        <p:spPr>
-          <a:xfrm>
-            <a:off x="11274552" y="6547104"/>
-            <a:ext cx="868680" cy="256032"/>
-          </a:xfrm>
-          <a:prstGeom prst="rect">
-            <a:avLst/>
-          </a:prstGeom>
-          <a:noFill/>
-        </p:spPr>
-        <p:txBody>
-          <a:bodyPr wrap="none" lIns="0" rIns="0" tIns="0" bIns="0">
-            <a:spAutoFit/>
-          </a:bodyPr>
-          <a:lstStyle/>
-          <a:p>
-            <a:pPr algn="r">
-              <a:lnSpc>
-                <a:spcPct val="100000"/>
-              </a:lnSpc>
-            </a:pPr>
-            <a:r>
-              <a:rPr sz="1000" i="1">
-                <a:solidFill>
-                  <a:srgbClr val="6B7685"/>
-                </a:solidFill>
-                <a:latin typeface="Arial"/>
-              </a:rPr>
-              <a:t>4 / 36</a:t>
-            </a:r>
-          </a:p>
-        </p:txBody>
-      </p:sp>
     </p:spTree>
   </p:cSld>
   <p:clrMapOvr>
@@ -45628,45 +44419,6 @@
           </a:p>
         </p:txBody>
       </p:sp>
-      <p:sp>
-        <p:nvSpPr>
-          <p:cNvPr id="33" name="TextBox 32"/>
-          <p:cNvSpPr txBox="1"/>
-          <p:nvPr/>
-        </p:nvSpPr>
-        <p:spPr>
-          <a:xfrm>
-            <a:off x="11274552" y="6547104"/>
-            <a:ext cx="868680" cy="256032"/>
-          </a:xfrm>
-          <a:prstGeom prst="rect">
-            <a:avLst/>
-          </a:prstGeom>
-          <a:noFill/>
-        </p:spPr>
-        <p:txBody>
-          <a:bodyPr wrap="none" lIns="0" rIns="0" tIns="0" bIns="0">
-            <a:spAutoFit/>
-          </a:bodyPr>
-          <a:lstStyle/>
-          <a:p>
-            <a:pPr algn="r">
-              <a:lnSpc>
-                <a:spcPct val="100000"/>
-              </a:lnSpc>
-            </a:pPr>
-            <a:r>
-              <a:rPr sz="1000" i="1">
-                <a:solidFill>
-                  <a:srgbClr val="6B7685"/>
-                </a:solidFill>
-                <a:latin typeface="Arial"/>
-              </a:rPr>
-              <a:t>5 / 36</a:t>
-            </a:r>
-          </a:p>
-        </p:txBody>
-      </p:sp>
     </p:spTree>
   </p:cSld>
   <p:clrMapOvr>
@@ -47141,45 +45893,6 @@
                 <a:latin typeface="Arial"/>
               </a:rPr>
               <a:t>Sibur</a:t>
-            </a:r>
-          </a:p>
-        </p:txBody>
-      </p:sp>
-      <p:sp>
-        <p:nvSpPr>
-          <p:cNvPr id="40" name="TextBox 39"/>
-          <p:cNvSpPr txBox="1"/>
-          <p:nvPr/>
-        </p:nvSpPr>
-        <p:spPr>
-          <a:xfrm>
-            <a:off x="11274552" y="6547104"/>
-            <a:ext cx="868680" cy="256032"/>
-          </a:xfrm>
-          <a:prstGeom prst="rect">
-            <a:avLst/>
-          </a:prstGeom>
-          <a:noFill/>
-        </p:spPr>
-        <p:txBody>
-          <a:bodyPr wrap="none" lIns="0" rIns="0" tIns="0" bIns="0">
-            <a:spAutoFit/>
-          </a:bodyPr>
-          <a:lstStyle/>
-          <a:p>
-            <a:pPr algn="r">
-              <a:lnSpc>
-                <a:spcPct val="100000"/>
-              </a:lnSpc>
-            </a:pPr>
-            <a:r>
-              <a:rPr sz="1000" i="1">
-                <a:solidFill>
-                  <a:srgbClr val="6B7685"/>
-                </a:solidFill>
-                <a:latin typeface="Arial"/>
-              </a:rPr>
-              <a:t>6 / 36</a:t>
             </a:r>
           </a:p>
         </p:txBody>
@@ -48287,45 +47000,6 @@
           </a:p>
         </p:txBody>
       </p:sp>
-      <p:sp>
-        <p:nvSpPr>
-          <p:cNvPr id="28" name="TextBox 27"/>
-          <p:cNvSpPr txBox="1"/>
-          <p:nvPr/>
-        </p:nvSpPr>
-        <p:spPr>
-          <a:xfrm>
-            <a:off x="11274552" y="6547104"/>
-            <a:ext cx="868680" cy="256032"/>
-          </a:xfrm>
-          <a:prstGeom prst="rect">
-            <a:avLst/>
-          </a:prstGeom>
-          <a:noFill/>
-        </p:spPr>
-        <p:txBody>
-          <a:bodyPr wrap="none" lIns="0" rIns="0" tIns="0" bIns="0">
-            <a:spAutoFit/>
-          </a:bodyPr>
-          <a:lstStyle/>
-          <a:p>
-            <a:pPr algn="r">
-              <a:lnSpc>
-                <a:spcPct val="100000"/>
-              </a:lnSpc>
-            </a:pPr>
-            <a:r>
-              <a:rPr sz="1000" i="1">
-                <a:solidFill>
-                  <a:srgbClr val="6B7685"/>
-                </a:solidFill>
-                <a:latin typeface="Arial"/>
-              </a:rPr>
-              <a:t>7 / 36</a:t>
-            </a:r>
-          </a:p>
-        </p:txBody>
-      </p:sp>
     </p:spTree>
   </p:cSld>
   <p:clrMapOvr>
@@ -49307,45 +47981,6 @@
           </a:p>
         </p:txBody>
       </p:sp>
-      <p:sp>
-        <p:nvSpPr>
-          <p:cNvPr id="22" name="TextBox 21"/>
-          <p:cNvSpPr txBox="1"/>
-          <p:nvPr/>
-        </p:nvSpPr>
-        <p:spPr>
-          <a:xfrm>
-            <a:off x="11274552" y="6547104"/>
-            <a:ext cx="868680" cy="256032"/>
-          </a:xfrm>
-          <a:prstGeom prst="rect">
-            <a:avLst/>
-          </a:prstGeom>
-          <a:noFill/>
-        </p:spPr>
-        <p:txBody>
-          <a:bodyPr wrap="none" lIns="0" rIns="0" tIns="0" bIns="0">
-            <a:spAutoFit/>
-          </a:bodyPr>
-          <a:lstStyle/>
-          <a:p>
-            <a:pPr algn="r">
-              <a:lnSpc>
-                <a:spcPct val="100000"/>
-              </a:lnSpc>
-            </a:pPr>
-            <a:r>
-              <a:rPr sz="1000" i="1">
-                <a:solidFill>
-                  <a:srgbClr val="6B7685"/>
-                </a:solidFill>
-                <a:latin typeface="Arial"/>
-              </a:rPr>
-              <a:t>8 / 36</a:t>
-            </a:r>
-          </a:p>
-        </p:txBody>
-      </p:sp>
     </p:spTree>
   </p:cSld>
   <p:clrMapOvr>
@@ -50043,45 +48678,6 @@
                 <a:hlinkClick r:id="rId3"/>
               </a:rPr>
               <a:t>McCulloch &amp; Pitts (1943)</a:t>
-            </a:r>
-          </a:p>
-        </p:txBody>
-      </p:sp>
-      <p:sp>
-        <p:nvSpPr>
-          <p:cNvPr id="18" name="TextBox 17"/>
-          <p:cNvSpPr txBox="1"/>
-          <p:nvPr/>
-        </p:nvSpPr>
-        <p:spPr>
-          <a:xfrm>
-            <a:off x="11274552" y="6547104"/>
-            <a:ext cx="868680" cy="256032"/>
-          </a:xfrm>
-          <a:prstGeom prst="rect">
-            <a:avLst/>
-          </a:prstGeom>
-          <a:noFill/>
-        </p:spPr>
-        <p:txBody>
-          <a:bodyPr wrap="none" lIns="0" rIns="0" tIns="0" bIns="0">
-            <a:spAutoFit/>
-          </a:bodyPr>
-          <a:lstStyle/>
-          <a:p>
-            <a:pPr algn="r">
-              <a:lnSpc>
-                <a:spcPct val="100000"/>
-              </a:lnSpc>
-            </a:pPr>
-            <a:r>
-              <a:rPr sz="1000" i="1">
-                <a:solidFill>
-                  <a:srgbClr val="6B7685"/>
-                </a:solidFill>
-                <a:latin typeface="Arial"/>
-              </a:rPr>
-              <a:t>9 / 36</a:t>
             </a:r>
           </a:p>
         </p:txBody>

</xml_diff>